<commit_message>
Kit 2: universal lab-exemplar retrofit, both editions
Ms. Rivera follows one artifact through the whole lab: her weekly
review-questions prompt, from rough first draft through three
iteration rounds to the saved bracketed template. Deck slides 19-21
show her work large as primary content; chips and script rivera-lines
name the same prompt at every step. TpT edition keeps the shared
staff doc as its save destination. Slide 28's long title narrowed to
clear the tracker chip, closing a pre-existing cosmetic flag.

Co-Authored-By: Claude Fable 5 <noreply@anthropic.com>
Claude-Session: https://claude.ai/code/session_019agQ42s1igQaB2X7GGat9R
</commit_message>
<xml_diff>
--- a/kits/kit02-tpt/Kit02_PresentationDeck.pptx
+++ b/kits/kit02-tpt/Kit02_PresentationDeck.pptx
@@ -1323,7 +1323,7 @@
           <a:p>
             <a:r>
               <a:rPr lang="en-US" dirty="0"/>
-              <a:t>Pairs, devices out inside two minutes, announce the tool. The script’s worked example under slide 19 is a real reusable prompt from a working carpentry program.</a:t>
+              <a:t>Pairs, devices out inside two minutes, announce the tool. Ms. Rivera builds ONE artifact across all three steps: her weekly review-questions prompt, first draft to saved template. Her exemplar appears large on every step slide; anyone lost can copy her structure and still finish. The script’s worked example under slide 19 is a real reusable prompt from a working carpentry program.</a:t>
             </a:r>
             <a:endParaRPr lang="en-US" dirty="0"/>
           </a:p>
@@ -1411,7 +1411,7 @@
           <a:p>
             <a:r>
               <a:rPr lang="en-US" dirty="0"/>
-              <a:t>Circulate. Weak prompts usually lack context; nudge with "what would a substitute need to know to do this right?" Then read the real carpentry CNC table-leg prompt from the script as the worked example (three stacked roles, one task, SVG-for-CNC format).</a:t>
+              <a:t>Circulate. Weak prompts usually lack context; nudge with "what would a substitute need to know to do this right?" The big card is Ms. Rivera's first draft for her weekly review questions, the one artifact she carries through all three steps, color-coded like slide 9; anyone stuck can copy its shape. Then read the real carpentry CNC table-leg prompt from the script as the worked example (three stacked roles, one task, SVG-for-CNC format).</a:t>
             </a:r>
             <a:endParaRPr lang="en-US" dirty="0"/>
           </a:p>
@@ -1587,7 +1587,7 @@
           <a:p>
             <a:r>
               <a:rPr lang="en-US" dirty="0"/>
-              <a:t>45-min cut: one round instead of three, then straight to step 3.</a:t>
+              <a:t>45-min cut: one round instead of three, then straight to step 3. The big card is Ms. Rivera's three typed pushback lines, all on the same review prompt from step 1: content, then voice, then details. Lost participants copy her rhythm with their own draft.</a:t>
             </a:r>
             <a:endParaRPr lang="en-US" dirty="0"/>
           </a:p>
@@ -1675,7 +1675,7 @@
           <a:p>
             <a:r>
               <a:rPr lang="en-US" dirty="0"/>
-              <a:t>Project the staff prompt doc link. Watching entries appear live is the session’s proudest moment.</a:t>
+              <a:t>Project the staff prompt doc link. Watching entries appear live is the session’s proudest moment. The big card is Ms. Rivera's finished template: the same review prompt from steps 1 and 2 with the specifics swapped for blanks, pasted under her name.</a:t>
             </a:r>
             <a:endParaRPr lang="en-US" dirty="0"/>
           </a:p>
@@ -1763,7 +1763,7 @@
           <a:p>
             <a:r>
               <a:rPr lang="en-US" dirty="0"/>
-              <a:t>One person reading their before AND after lets the room hear the delta. Keep each voice to a minute.</a:t>
+              <a:t>One person reading their before AND after lets the room hear the delta. Keep each voice to a minute. If the room is shy, read Ms. Rivera's delta yourself: her step 1 draft against her step 3 template.</a:t>
             </a:r>
             <a:endParaRPr lang="en-US" dirty="0"/>
           </a:p>
@@ -9818,7 +9818,7 @@
                 <a:ea typeface="Inter" pitchFamily="34" charset="-122"/>
                 <a:cs typeface="Inter" pitchFamily="34" charset="-120"/>
               </a:rPr>
-              <a:t>Her lab pick: the Friday newsletter. Weekly task, real payoff.</a:t>
+              <a:t>Her lab pick, one prompt through every step: her weekly review questions.</a:t>
             </a:r>
             <a:endParaRPr lang="en-US" sz="1000" dirty="0"/>
           </a:p>
@@ -9911,7 +9911,7 @@
         <p:spPr>
           <a:xfrm>
             <a:off x="640080" y="2377440"/>
-            <a:ext cx="10972800" cy="822960"/>
+            <a:ext cx="10972800" cy="914400"/>
           </a:xfrm>
           <a:prstGeom prst="rect">
             <a:avLst/>
@@ -9935,7 +9935,7 @@
                 <a:ea typeface="Inter" pitchFamily="34" charset="-122"/>
                 <a:cs typeface="Inter" pitchFamily="34" charset="-120"/>
               </a:rPr>
-              <a:t>Pick one task you do every week: the Friday newsletter, the weekly quiz, leveling a reading, station directions.</a:t>
+              <a:t>Pick one task you do every week: the Friday newsletter, the weekly quiz, leveling a reading, station directions. Ms. Rivera builds hers on screen the whole way: one prompt for her weekly review questions.</a:t>
             </a:r>
             <a:endParaRPr lang="en-US" sz="2000" dirty="0"/>
           </a:p>
@@ -10599,7 +10599,7 @@
                 <a:ea typeface="Inter" pitchFamily="34" charset="-122"/>
                 <a:cs typeface="Inter" pitchFamily="34" charset="-120"/>
               </a:rPr>
-              <a:t>On her screen: the four-part draft, run once, read like an editor.</a:t>
+              <a:t>Her review prompt, draft one: all four parts in, run once, read like an editor.</a:t>
             </a:r>
             <a:endParaRPr lang="en-US" sz="1000" dirty="0"/>
           </a:p>
@@ -10692,7 +10692,7 @@
         <p:spPr>
           <a:xfrm>
             <a:off x="640080" y="1508760"/>
-            <a:ext cx="10972800" cy="731520"/>
+            <a:ext cx="4892040" cy="731520"/>
           </a:xfrm>
           <a:prstGeom prst="roundRect">
             <a:avLst>
@@ -10718,24 +10718,24 @@
         </p:nvSpPr>
         <p:spPr>
           <a:xfrm>
-            <a:off x="960120" y="1563624"/>
-            <a:ext cx="10332720" cy="621792"/>
-          </a:xfrm>
-          <a:prstGeom prst="rect">
-            <a:avLst/>
-          </a:prstGeom>
-          <a:noFill/>
-          <a:ln/>
-        </p:spPr>
-        <p:txBody>
-          <a:bodyPr wrap="square" lIns="0" tIns="0" rIns="0" bIns="0" rtlCol="0" anchor="ctr"/>
-          <a:lstStyle/>
-          <a:p>
-            <a:pPr indent="0" marL="0">
-              <a:buNone/>
-            </a:pPr>
-            <a:r>
-              <a:rPr lang="en-US" sz="1900" dirty="0">
+            <a:off x="914400" y="1563624"/>
+            <a:ext cx="4389120" cy="621792"/>
+          </a:xfrm>
+          <a:prstGeom prst="rect">
+            <a:avLst/>
+          </a:prstGeom>
+          <a:noFill/>
+          <a:ln/>
+        </p:spPr>
+        <p:txBody>
+          <a:bodyPr wrap="square" lIns="0" tIns="0" rIns="0" bIns="0" rtlCol="0" anchor="ctr"/>
+          <a:lstStyle/>
+          <a:p>
+            <a:pPr indent="0" marL="0">
+              <a:buNone/>
+            </a:pPr>
+            <a:r>
+              <a:rPr lang="en-US" sz="1550" dirty="0">
                 <a:solidFill>
                   <a:srgbClr val="1B1F24"/>
                 </a:solidFill>
@@ -10745,7 +10745,7 @@
               </a:rPr>
               <a:t>Role: who should it be?</a:t>
             </a:r>
-            <a:endParaRPr lang="en-US" sz="1900" dirty="0"/>
+            <a:endParaRPr lang="en-US" sz="1550" dirty="0"/>
           </a:p>
         </p:txBody>
       </p:sp>
@@ -10758,7 +10758,7 @@
         <p:spPr>
           <a:xfrm>
             <a:off x="640080" y="2377440"/>
-            <a:ext cx="10972800" cy="731520"/>
+            <a:ext cx="4892040" cy="731520"/>
           </a:xfrm>
           <a:prstGeom prst="roundRect">
             <a:avLst>
@@ -10784,24 +10784,24 @@
         </p:nvSpPr>
         <p:spPr>
           <a:xfrm>
-            <a:off x="960120" y="2432304"/>
-            <a:ext cx="10332720" cy="621792"/>
-          </a:xfrm>
-          <a:prstGeom prst="rect">
-            <a:avLst/>
-          </a:prstGeom>
-          <a:noFill/>
-          <a:ln/>
-        </p:spPr>
-        <p:txBody>
-          <a:bodyPr wrap="square" lIns="0" tIns="0" rIns="0" bIns="0" rtlCol="0" anchor="ctr"/>
-          <a:lstStyle/>
-          <a:p>
-            <a:pPr indent="0" marL="0">
-              <a:buNone/>
-            </a:pPr>
-            <a:r>
-              <a:rPr lang="en-US" sz="1900" dirty="0">
+            <a:off x="914400" y="2432304"/>
+            <a:ext cx="4389120" cy="621792"/>
+          </a:xfrm>
+          <a:prstGeom prst="rect">
+            <a:avLst/>
+          </a:prstGeom>
+          <a:noFill/>
+          <a:ln/>
+        </p:spPr>
+        <p:txBody>
+          <a:bodyPr wrap="square" lIns="0" tIns="0" rIns="0" bIns="0" rtlCol="0" anchor="ctr"/>
+          <a:lstStyle/>
+          <a:p>
+            <a:pPr indent="0" marL="0">
+              <a:buNone/>
+            </a:pPr>
+            <a:r>
+              <a:rPr lang="en-US" sz="1550" dirty="0">
                 <a:solidFill>
                   <a:srgbClr val="1B1F24"/>
                 </a:solidFill>
@@ -10811,7 +10811,7 @@
               </a:rPr>
               <a:t>Task: one clear verb</a:t>
             </a:r>
-            <a:endParaRPr lang="en-US" sz="1900" dirty="0"/>
+            <a:endParaRPr lang="en-US" sz="1550" dirty="0"/>
           </a:p>
         </p:txBody>
       </p:sp>
@@ -10824,7 +10824,7 @@
         <p:spPr>
           <a:xfrm>
             <a:off x="640080" y="3246120"/>
-            <a:ext cx="10972800" cy="731520"/>
+            <a:ext cx="4892040" cy="731520"/>
           </a:xfrm>
           <a:prstGeom prst="roundRect">
             <a:avLst>
@@ -10850,24 +10850,24 @@
         </p:nvSpPr>
         <p:spPr>
           <a:xfrm>
-            <a:off x="960120" y="3300984"/>
-            <a:ext cx="10332720" cy="621792"/>
-          </a:xfrm>
-          <a:prstGeom prst="rect">
-            <a:avLst/>
-          </a:prstGeom>
-          <a:noFill/>
-          <a:ln/>
-        </p:spPr>
-        <p:txBody>
-          <a:bodyPr wrap="square" lIns="0" tIns="0" rIns="0" bIns="0" rtlCol="0" anchor="ctr"/>
-          <a:lstStyle/>
-          <a:p>
-            <a:pPr indent="0" marL="0">
-              <a:buNone/>
-            </a:pPr>
-            <a:r>
-              <a:rPr lang="en-US" sz="1900" dirty="0">
+            <a:off x="914400" y="3300984"/>
+            <a:ext cx="4389120" cy="621792"/>
+          </a:xfrm>
+          <a:prstGeom prst="rect">
+            <a:avLst/>
+          </a:prstGeom>
+          <a:noFill/>
+          <a:ln/>
+        </p:spPr>
+        <p:txBody>
+          <a:bodyPr wrap="square" lIns="0" tIns="0" rIns="0" bIns="0" rtlCol="0" anchor="ctr"/>
+          <a:lstStyle/>
+          <a:p>
+            <a:pPr indent="0" marL="0">
+              <a:buNone/>
+            </a:pPr>
+            <a:r>
+              <a:rPr lang="en-US" sz="1550" dirty="0">
                 <a:solidFill>
                   <a:srgbClr val="1B1F24"/>
                 </a:solidFill>
@@ -10877,7 +10877,7 @@
               </a:rPr>
               <a:t>Context: what would a substitute need to know?</a:t>
             </a:r>
-            <a:endParaRPr lang="en-US" sz="1900" dirty="0"/>
+            <a:endParaRPr lang="en-US" sz="1550" dirty="0"/>
           </a:p>
         </p:txBody>
       </p:sp>
@@ -10890,7 +10890,7 @@
         <p:spPr>
           <a:xfrm>
             <a:off x="640080" y="4114800"/>
-            <a:ext cx="10972800" cy="731520"/>
+            <a:ext cx="4892040" cy="731520"/>
           </a:xfrm>
           <a:prstGeom prst="roundRect">
             <a:avLst>
@@ -10916,24 +10916,24 @@
         </p:nvSpPr>
         <p:spPr>
           <a:xfrm>
-            <a:off x="960120" y="4169664"/>
-            <a:ext cx="10332720" cy="621792"/>
-          </a:xfrm>
-          <a:prstGeom prst="rect">
-            <a:avLst/>
-          </a:prstGeom>
-          <a:noFill/>
-          <a:ln/>
-        </p:spPr>
-        <p:txBody>
-          <a:bodyPr wrap="square" lIns="0" tIns="0" rIns="0" bIns="0" rtlCol="0" anchor="ctr"/>
-          <a:lstStyle/>
-          <a:p>
-            <a:pPr indent="0" marL="0">
-              <a:buNone/>
-            </a:pPr>
-            <a:r>
-              <a:rPr lang="en-US" sz="1900" dirty="0">
+            <a:off x="914400" y="4169664"/>
+            <a:ext cx="4389120" cy="621792"/>
+          </a:xfrm>
+          <a:prstGeom prst="rect">
+            <a:avLst/>
+          </a:prstGeom>
+          <a:noFill/>
+          <a:ln/>
+        </p:spPr>
+        <p:txBody>
+          <a:bodyPr wrap="square" lIns="0" tIns="0" rIns="0" bIns="0" rtlCol="0" anchor="ctr"/>
+          <a:lstStyle/>
+          <a:p>
+            <a:pPr indent="0" marL="0">
+              <a:buNone/>
+            </a:pPr>
+            <a:r>
+              <a:rPr lang="en-US" sz="1550" dirty="0">
                 <a:solidFill>
                   <a:srgbClr val="1B1F24"/>
                 </a:solidFill>
@@ -10943,13 +10943,211 @@
               </a:rPr>
               <a:t>Format: exactly what the output looks like</a:t>
             </a:r>
-            <a:endParaRPr lang="en-US" sz="1900" dirty="0"/>
-          </a:p>
-        </p:txBody>
-      </p:sp>
-      <p:sp>
-        <p:nvSpPr>
-          <p:cNvPr id="22" name="Text 19"/>
+            <a:endParaRPr lang="en-US" sz="1550" dirty="0"/>
+          </a:p>
+        </p:txBody>
+      </p:sp>
+      <p:sp>
+        <p:nvSpPr>
+          <p:cNvPr id="22" name="Shape 19"/>
+          <p:cNvSpPr/>
+          <p:nvPr/>
+        </p:nvSpPr>
+        <p:spPr>
+          <a:xfrm>
+            <a:off x="5806440" y="1508760"/>
+            <a:ext cx="5806440" cy="3429000"/>
+          </a:xfrm>
+          <a:prstGeom prst="roundRect">
+            <a:avLst>
+              <a:gd name="adj" fmla="val 2400"/>
+            </a:avLst>
+          </a:prstGeom>
+          <a:solidFill>
+            <a:srgbClr val="EAF5F3"/>
+          </a:solidFill>
+          <a:ln w="12700">
+            <a:solidFill>
+              <a:srgbClr val="EAF5F3"/>
+            </a:solidFill>
+            <a:prstDash val="solid"/>
+          </a:ln>
+        </p:spPr>
+      </p:sp>
+      <p:sp>
+        <p:nvSpPr>
+          <p:cNvPr id="23" name="Text 20"/>
+          <p:cNvSpPr/>
+          <p:nvPr/>
+        </p:nvSpPr>
+        <p:spPr>
+          <a:xfrm>
+            <a:off x="6080760" y="1691640"/>
+            <a:ext cx="5349240" cy="292608"/>
+          </a:xfrm>
+          <a:prstGeom prst="rect">
+            <a:avLst/>
+          </a:prstGeom>
+          <a:noFill/>
+          <a:ln/>
+        </p:spPr>
+        <p:txBody>
+          <a:bodyPr wrap="square" lIns="0" tIns="0" rIns="0" bIns="0" rtlCol="0" anchor="ctr"/>
+          <a:lstStyle/>
+          <a:p>
+            <a:pPr indent="0" marL="0">
+              <a:buNone/>
+            </a:pPr>
+            <a:r>
+              <a:rPr lang="en-US" sz="1250" b="1" spc="150" kern="0" dirty="0">
+                <a:solidFill>
+                  <a:srgbClr val="2A9D8F"/>
+                </a:solidFill>
+                <a:latin typeface="Inter" pitchFamily="34" charset="0"/>
+                <a:ea typeface="Inter" pitchFamily="34" charset="-122"/>
+                <a:cs typeface="Inter" pitchFamily="34" charset="-120"/>
+              </a:rPr>
+              <a:t>MS. RIVERA'S REVIEW PROMPT · STEP 1 · HER FIRST DRAFT</a:t>
+            </a:r>
+            <a:endParaRPr lang="en-US" sz="1250" dirty="0"/>
+          </a:p>
+        </p:txBody>
+      </p:sp>
+      <p:sp>
+        <p:nvSpPr>
+          <p:cNvPr id="24" name="Text 21"/>
+          <p:cNvSpPr/>
+          <p:nvPr/>
+        </p:nvSpPr>
+        <p:spPr>
+          <a:xfrm>
+            <a:off x="6080760" y="2103120"/>
+            <a:ext cx="5257800" cy="2331720"/>
+          </a:xfrm>
+          <a:prstGeom prst="rect">
+            <a:avLst/>
+          </a:prstGeom>
+          <a:noFill/>
+          <a:ln/>
+        </p:spPr>
+        <p:txBody>
+          <a:bodyPr wrap="square" lIns="0" tIns="0" rIns="0" bIns="0" rtlCol="0" anchor="t"/>
+          <a:lstStyle/>
+          <a:p>
+            <a:pPr indent="0" marL="0">
+              <a:lnSpc>
+                <a:spcPct val="120000"/>
+              </a:lnSpc>
+              <a:buNone/>
+            </a:pPr>
+            <a:r>
+              <a:rPr lang="en-US" sz="1700" b="1" dirty="0">
+                <a:solidFill>
+                  <a:srgbClr val="2A9D8F"/>
+                </a:solidFill>
+                <a:latin typeface="Inter" pitchFamily="34" charset="0"/>
+                <a:ea typeface="Inter" pitchFamily="34" charset="-122"/>
+                <a:cs typeface="Inter" pitchFamily="34" charset="-120"/>
+              </a:rPr>
+              <a:t>“You are an experienced 4th grade teacher. </a:t>
+            </a:r>
+            <a:pPr indent="0" marL="0">
+              <a:lnSpc>
+                <a:spcPct val="120000"/>
+              </a:lnSpc>
+              <a:buNone/>
+            </a:pPr>
+            <a:r>
+              <a:rPr lang="en-US" sz="1700" b="1" dirty="0">
+                <a:solidFill>
+                  <a:srgbClr val="13293D"/>
+                </a:solidFill>
+                <a:latin typeface="Inter" pitchFamily="34" charset="0"/>
+                <a:ea typeface="Inter" pitchFamily="34" charset="-122"/>
+                <a:cs typeface="Inter" pitchFamily="34" charset="-120"/>
+              </a:rPr>
+              <a:t>Write a 10-question Friday review on equivalent fractions </a:t>
+            </a:r>
+            <a:pPr indent="0" marL="0">
+              <a:lnSpc>
+                <a:spcPct val="120000"/>
+              </a:lnSpc>
+              <a:buNone/>
+            </a:pPr>
+            <a:r>
+              <a:rPr lang="en-US" sz="1700" b="1" dirty="0">
+                <a:solidFill>
+                  <a:srgbClr val="B07914"/>
+                </a:solidFill>
+                <a:latin typeface="Inter" pitchFamily="34" charset="0"/>
+                <a:ea typeface="Inter" pitchFamily="34" charset="-122"/>
+                <a:cs typeface="Inter" pitchFamily="34" charset="-120"/>
+              </a:rPr>
+              <a:t>for a class that still confuses numerator and denominator when simplifying. </a:t>
+            </a:r>
+            <a:pPr indent="0" marL="0">
+              <a:lnSpc>
+                <a:spcPct val="120000"/>
+              </a:lnSpc>
+              <a:buNone/>
+            </a:pPr>
+            <a:r>
+              <a:rPr lang="en-US" sz="1700" b="1" dirty="0">
+                <a:solidFill>
+                  <a:srgbClr val="2E7D5B"/>
+                </a:solidFill>
+                <a:latin typeface="Inter" pitchFamily="34" charset="0"/>
+                <a:ea typeface="Inter" pitchFamily="34" charset="-122"/>
+                <a:cs typeface="Inter" pitchFamily="34" charset="-120"/>
+              </a:rPr>
+              <a:t>Mix multiple choice and short answer. Include an answer key.”</a:t>
+            </a:r>
+            <a:endParaRPr lang="en-US" sz="1700" dirty="0"/>
+          </a:p>
+        </p:txBody>
+      </p:sp>
+      <p:sp>
+        <p:nvSpPr>
+          <p:cNvPr id="25" name="Text 22"/>
+          <p:cNvSpPr/>
+          <p:nvPr/>
+        </p:nvSpPr>
+        <p:spPr>
+          <a:xfrm>
+            <a:off x="6080760" y="4480560"/>
+            <a:ext cx="5257800" cy="365760"/>
+          </a:xfrm>
+          <a:prstGeom prst="rect">
+            <a:avLst/>
+          </a:prstGeom>
+          <a:noFill/>
+          <a:ln/>
+        </p:spPr>
+        <p:txBody>
+          <a:bodyPr wrap="square" lIns="0" tIns="0" rIns="0" bIns="0" rtlCol="0" anchor="ctr"/>
+          <a:lstStyle/>
+          <a:p>
+            <a:pPr indent="0" marL="0">
+              <a:buNone/>
+            </a:pPr>
+            <a:r>
+              <a:rPr lang="en-US" sz="1300" i="1" dirty="0">
+                <a:solidFill>
+                  <a:srgbClr val="5B6B7A"/>
+                </a:solidFill>
+                <a:latin typeface="Inter" pitchFamily="34" charset="0"/>
+                <a:ea typeface="Inter" pitchFamily="34" charset="-122"/>
+                <a:cs typeface="Inter" pitchFamily="34" charset="-120"/>
+              </a:rPr>
+              <a:t>Same colors as the makeover: role, task, context, format.</a:t>
+            </a:r>
+            <a:endParaRPr lang="en-US" sz="1300" dirty="0"/>
+          </a:p>
+        </p:txBody>
+      </p:sp>
+      <p:sp>
+        <p:nvSpPr>
+          <p:cNvPr id="26" name="Text 23"/>
           <p:cNvSpPr/>
           <p:nvPr/>
         </p:nvSpPr>
@@ -12085,7 +12283,7 @@
                 <a:ea typeface="Inter" pitchFamily="34" charset="-122"/>
                 <a:cs typeface="Inter" pitchFamily="34" charset="-120"/>
               </a:rPr>
-              <a:t>Her three rounds, live: fixed content, warmed the voice, tightened details.</a:t>
+              <a:t>Her review prompt, three rounds in: content fixed, voice warmed, details tight.</a:t>
             </a:r>
             <a:endParaRPr lang="en-US" sz="1000" dirty="0"/>
           </a:p>
@@ -12177,12 +12375,12 @@
         </p:nvSpPr>
         <p:spPr>
           <a:xfrm>
-            <a:off x="640080" y="1554480"/>
-            <a:ext cx="3520440" cy="2926080"/>
+            <a:off x="640080" y="1508760"/>
+            <a:ext cx="4160520" cy="1051560"/>
           </a:xfrm>
           <a:prstGeom prst="roundRect">
             <a:avLst>
-              <a:gd name="adj" fmla="val 2813"/>
+              <a:gd name="adj" fmla="val 7826"/>
             </a:avLst>
           </a:prstGeom>
           <a:solidFill>
@@ -12198,28 +12396,42 @@
       </p:sp>
       <p:sp>
         <p:nvSpPr>
-          <p:cNvPr id="15" name="Shape 12"/>
-          <p:cNvSpPr/>
-          <p:nvPr/>
-        </p:nvSpPr>
-        <p:spPr>
-          <a:xfrm>
-            <a:off x="1938528" y="1828800"/>
-            <a:ext cx="914400" cy="914400"/>
-          </a:xfrm>
-          <a:prstGeom prst="ellipse">
-            <a:avLst/>
-          </a:prstGeom>
-          <a:solidFill>
-            <a:srgbClr val="2A9D8F"/>
-          </a:solidFill>
-          <a:ln w="12700">
-            <a:solidFill>
-              <a:srgbClr val="2A9D8F"/>
-            </a:solidFill>
-            <a:prstDash val="solid"/>
-          </a:ln>
-        </p:spPr>
+          <p:cNvPr id="15" name="Text 12"/>
+          <p:cNvSpPr/>
+          <p:nvPr/>
+        </p:nvSpPr>
+        <p:spPr>
+          <a:xfrm>
+            <a:off x="914400" y="1618488"/>
+            <a:ext cx="3657600" cy="365760"/>
+          </a:xfrm>
+          <a:prstGeom prst="rect">
+            <a:avLst/>
+          </a:prstGeom>
+          <a:noFill/>
+          <a:ln/>
+        </p:spPr>
+        <p:txBody>
+          <a:bodyPr wrap="square" lIns="0" tIns="0" rIns="0" bIns="0" rtlCol="0" anchor="ctr"/>
+          <a:lstStyle/>
+          <a:p>
+            <a:pPr indent="0" marL="0">
+              <a:buNone/>
+            </a:pPr>
+            <a:r>
+              <a:rPr lang="en-US" sz="1700" b="1" dirty="0">
+                <a:solidFill>
+                  <a:srgbClr val="13293D"/>
+                </a:solidFill>
+                <a:latin typeface="Inter" pitchFamily="34" charset="0"/>
+                <a:ea typeface="Inter" pitchFamily="34" charset="-122"/>
+                <a:cs typeface="Inter" pitchFamily="34" charset="-120"/>
+              </a:rPr>
+              <a:t>1 · Content</a:t>
+            </a:r>
+            <a:endParaRPr lang="en-US" sz="1700" dirty="0"/>
+          </a:p>
+        </p:txBody>
       </p:sp>
       <p:sp>
         <p:nvSpPr>
@@ -12229,102 +12441,24 @@
         </p:nvSpPr>
         <p:spPr>
           <a:xfrm>
-            <a:off x="1938528" y="1828800"/>
-            <a:ext cx="914400" cy="914400"/>
-          </a:xfrm>
-          <a:prstGeom prst="rect">
-            <a:avLst/>
-          </a:prstGeom>
-          <a:noFill/>
-          <a:ln/>
-        </p:spPr>
-        <p:txBody>
-          <a:bodyPr wrap="square" lIns="0" tIns="0" rIns="0" bIns="0" rtlCol="0" anchor="ctr"/>
-          <a:lstStyle/>
-          <a:p>
-            <a:pPr algn="ctr" indent="0" marL="0">
-              <a:buNone/>
-            </a:pPr>
-            <a:r>
-              <a:rPr lang="en-US" sz="3000" b="1" dirty="0">
-                <a:solidFill>
-                  <a:srgbClr val="FFFFFF"/>
-                </a:solidFill>
-                <a:latin typeface="Inter" pitchFamily="34" charset="0"/>
-                <a:ea typeface="Inter" pitchFamily="34" charset="-122"/>
-                <a:cs typeface="Inter" pitchFamily="34" charset="-120"/>
-              </a:rPr>
-              <a:t>1</a:t>
-            </a:r>
-            <a:endParaRPr lang="en-US" sz="3000" dirty="0"/>
-          </a:p>
-        </p:txBody>
-      </p:sp>
-      <p:sp>
-        <p:nvSpPr>
-          <p:cNvPr id="17" name="Text 14"/>
-          <p:cNvSpPr/>
-          <p:nvPr/>
-        </p:nvSpPr>
-        <p:spPr>
-          <a:xfrm>
-            <a:off x="868680" y="2926080"/>
-            <a:ext cx="3063240" cy="457200"/>
-          </a:xfrm>
-          <a:prstGeom prst="rect">
-            <a:avLst/>
-          </a:prstGeom>
-          <a:noFill/>
-          <a:ln/>
-        </p:spPr>
-        <p:txBody>
-          <a:bodyPr wrap="square" lIns="0" tIns="0" rIns="0" bIns="0" rtlCol="0" anchor="ctr"/>
-          <a:lstStyle/>
-          <a:p>
-            <a:pPr algn="ctr" indent="0" marL="0">
-              <a:buNone/>
-            </a:pPr>
-            <a:r>
-              <a:rPr lang="en-US" sz="2000" b="1" dirty="0">
-                <a:solidFill>
-                  <a:srgbClr val="13293D"/>
-                </a:solidFill>
-                <a:latin typeface="Inter" pitchFamily="34" charset="0"/>
-                <a:ea typeface="Inter" pitchFamily="34" charset="-122"/>
-                <a:cs typeface="Inter" pitchFamily="34" charset="-120"/>
-              </a:rPr>
-              <a:t>Content</a:t>
-            </a:r>
-            <a:endParaRPr lang="en-US" sz="2000" dirty="0"/>
-          </a:p>
-        </p:txBody>
-      </p:sp>
-      <p:sp>
-        <p:nvSpPr>
-          <p:cNvPr id="18" name="Text 15"/>
-          <p:cNvSpPr/>
-          <p:nvPr/>
-        </p:nvSpPr>
-        <p:spPr>
-          <a:xfrm>
-            <a:off x="868680" y="3429000"/>
-            <a:ext cx="3063240" cy="914400"/>
-          </a:xfrm>
-          <a:prstGeom prst="rect">
-            <a:avLst/>
-          </a:prstGeom>
-          <a:noFill/>
-          <a:ln/>
-        </p:spPr>
-        <p:txBody>
-          <a:bodyPr wrap="square" lIns="0" tIns="0" rIns="0" bIns="0" rtlCol="0" anchor="ctr"/>
-          <a:lstStyle/>
-          <a:p>
-            <a:pPr algn="ctr" indent="0" marL="0">
-              <a:buNone/>
-            </a:pPr>
-            <a:r>
-              <a:rPr lang="en-US" sz="1500" dirty="0">
+            <a:off x="914400" y="1984248"/>
+            <a:ext cx="3657600" cy="502920"/>
+          </a:xfrm>
+          <a:prstGeom prst="rect">
+            <a:avLst/>
+          </a:prstGeom>
+          <a:noFill/>
+          <a:ln/>
+        </p:spPr>
+        <p:txBody>
+          <a:bodyPr wrap="square" lIns="0" tIns="0" rIns="0" bIns="0" rtlCol="0" anchor="ctr"/>
+          <a:lstStyle/>
+          <a:p>
+            <a:pPr indent="0" marL="0">
+              <a:buNone/>
+            </a:pPr>
+            <a:r>
+              <a:rPr lang="en-US" sz="1350" dirty="0">
                 <a:solidFill>
                   <a:srgbClr val="1B1F24"/>
                 </a:solidFill>
@@ -12334,24 +12468,24 @@
               </a:rPr>
               <a:t>What’s wrong or missing? Fix it first.</a:t>
             </a:r>
-            <a:endParaRPr lang="en-US" sz="1500" dirty="0"/>
-          </a:p>
-        </p:txBody>
-      </p:sp>
-      <p:sp>
-        <p:nvSpPr>
-          <p:cNvPr id="19" name="Shape 16"/>
-          <p:cNvSpPr/>
-          <p:nvPr/>
-        </p:nvSpPr>
-        <p:spPr>
-          <a:xfrm>
-            <a:off x="4407408" y="1554480"/>
-            <a:ext cx="3520440" cy="2926080"/>
+            <a:endParaRPr lang="en-US" sz="1350" dirty="0"/>
+          </a:p>
+        </p:txBody>
+      </p:sp>
+      <p:sp>
+        <p:nvSpPr>
+          <p:cNvPr id="17" name="Shape 14"/>
+          <p:cNvSpPr/>
+          <p:nvPr/>
+        </p:nvSpPr>
+        <p:spPr>
+          <a:xfrm>
+            <a:off x="640080" y="2697480"/>
+            <a:ext cx="4160520" cy="1051560"/>
           </a:xfrm>
           <a:prstGeom prst="roundRect">
             <a:avLst>
-              <a:gd name="adj" fmla="val 2813"/>
+              <a:gd name="adj" fmla="val 7826"/>
             </a:avLst>
           </a:prstGeom>
           <a:solidFill>
@@ -12367,160 +12501,96 @@
       </p:sp>
       <p:sp>
         <p:nvSpPr>
+          <p:cNvPr id="18" name="Text 15"/>
+          <p:cNvSpPr/>
+          <p:nvPr/>
+        </p:nvSpPr>
+        <p:spPr>
+          <a:xfrm>
+            <a:off x="914400" y="2807208"/>
+            <a:ext cx="3657600" cy="365760"/>
+          </a:xfrm>
+          <a:prstGeom prst="rect">
+            <a:avLst/>
+          </a:prstGeom>
+          <a:noFill/>
+          <a:ln/>
+        </p:spPr>
+        <p:txBody>
+          <a:bodyPr wrap="square" lIns="0" tIns="0" rIns="0" bIns="0" rtlCol="0" anchor="ctr"/>
+          <a:lstStyle/>
+          <a:p>
+            <a:pPr indent="0" marL="0">
+              <a:buNone/>
+            </a:pPr>
+            <a:r>
+              <a:rPr lang="en-US" sz="1700" b="1" dirty="0">
+                <a:solidFill>
+                  <a:srgbClr val="13293D"/>
+                </a:solidFill>
+                <a:latin typeface="Inter" pitchFamily="34" charset="0"/>
+                <a:ea typeface="Inter" pitchFamily="34" charset="-122"/>
+                <a:cs typeface="Inter" pitchFamily="34" charset="-120"/>
+              </a:rPr>
+              <a:t>2 · Voice</a:t>
+            </a:r>
+            <a:endParaRPr lang="en-US" sz="1700" dirty="0"/>
+          </a:p>
+        </p:txBody>
+      </p:sp>
+      <p:sp>
+        <p:nvSpPr>
+          <p:cNvPr id="19" name="Text 16"/>
+          <p:cNvSpPr/>
+          <p:nvPr/>
+        </p:nvSpPr>
+        <p:spPr>
+          <a:xfrm>
+            <a:off x="914400" y="3172968"/>
+            <a:ext cx="3657600" cy="502920"/>
+          </a:xfrm>
+          <a:prstGeom prst="rect">
+            <a:avLst/>
+          </a:prstGeom>
+          <a:noFill/>
+          <a:ln/>
+        </p:spPr>
+        <p:txBody>
+          <a:bodyPr wrap="square" lIns="0" tIns="0" rIns="0" bIns="0" rtlCol="0" anchor="ctr"/>
+          <a:lstStyle/>
+          <a:p>
+            <a:pPr indent="0" marL="0">
+              <a:buNone/>
+            </a:pPr>
+            <a:r>
+              <a:rPr lang="en-US" sz="1350" dirty="0">
+                <a:solidFill>
+                  <a:srgbClr val="1B1F24"/>
+                </a:solidFill>
+                <a:latin typeface="Inter" pitchFamily="34" charset="0"/>
+                <a:ea typeface="Inter" pitchFamily="34" charset="-122"/>
+                <a:cs typeface="Inter" pitchFamily="34" charset="-120"/>
+              </a:rPr>
+              <a:t>Does it sound like you? Read it aloud.</a:t>
+            </a:r>
+            <a:endParaRPr lang="en-US" sz="1350" dirty="0"/>
+          </a:p>
+        </p:txBody>
+      </p:sp>
+      <p:sp>
+        <p:nvSpPr>
           <p:cNvPr id="20" name="Shape 17"/>
           <p:cNvSpPr/>
           <p:nvPr/>
         </p:nvSpPr>
         <p:spPr>
           <a:xfrm>
-            <a:off x="5705856" y="1828800"/>
-            <a:ext cx="914400" cy="914400"/>
-          </a:xfrm>
-          <a:prstGeom prst="ellipse">
-            <a:avLst/>
-          </a:prstGeom>
-          <a:solidFill>
-            <a:srgbClr val="2A9D8F"/>
-          </a:solidFill>
-          <a:ln w="12700">
-            <a:solidFill>
-              <a:srgbClr val="2A9D8F"/>
-            </a:solidFill>
-            <a:prstDash val="solid"/>
-          </a:ln>
-        </p:spPr>
-      </p:sp>
-      <p:sp>
-        <p:nvSpPr>
-          <p:cNvPr id="21" name="Text 18"/>
-          <p:cNvSpPr/>
-          <p:nvPr/>
-        </p:nvSpPr>
-        <p:spPr>
-          <a:xfrm>
-            <a:off x="5705856" y="1828800"/>
-            <a:ext cx="914400" cy="914400"/>
-          </a:xfrm>
-          <a:prstGeom prst="rect">
-            <a:avLst/>
-          </a:prstGeom>
-          <a:noFill/>
-          <a:ln/>
-        </p:spPr>
-        <p:txBody>
-          <a:bodyPr wrap="square" lIns="0" tIns="0" rIns="0" bIns="0" rtlCol="0" anchor="ctr"/>
-          <a:lstStyle/>
-          <a:p>
-            <a:pPr algn="ctr" indent="0" marL="0">
-              <a:buNone/>
-            </a:pPr>
-            <a:r>
-              <a:rPr lang="en-US" sz="3000" b="1" dirty="0">
-                <a:solidFill>
-                  <a:srgbClr val="FFFFFF"/>
-                </a:solidFill>
-                <a:latin typeface="Inter" pitchFamily="34" charset="0"/>
-                <a:ea typeface="Inter" pitchFamily="34" charset="-122"/>
-                <a:cs typeface="Inter" pitchFamily="34" charset="-120"/>
-              </a:rPr>
-              <a:t>2</a:t>
-            </a:r>
-            <a:endParaRPr lang="en-US" sz="3000" dirty="0"/>
-          </a:p>
-        </p:txBody>
-      </p:sp>
-      <p:sp>
-        <p:nvSpPr>
-          <p:cNvPr id="22" name="Text 19"/>
-          <p:cNvSpPr/>
-          <p:nvPr/>
-        </p:nvSpPr>
-        <p:spPr>
-          <a:xfrm>
-            <a:off x="4636008" y="2926080"/>
-            <a:ext cx="3063240" cy="457200"/>
-          </a:xfrm>
-          <a:prstGeom prst="rect">
-            <a:avLst/>
-          </a:prstGeom>
-          <a:noFill/>
-          <a:ln/>
-        </p:spPr>
-        <p:txBody>
-          <a:bodyPr wrap="square" lIns="0" tIns="0" rIns="0" bIns="0" rtlCol="0" anchor="ctr"/>
-          <a:lstStyle/>
-          <a:p>
-            <a:pPr algn="ctr" indent="0" marL="0">
-              <a:buNone/>
-            </a:pPr>
-            <a:r>
-              <a:rPr lang="en-US" sz="2000" b="1" dirty="0">
-                <a:solidFill>
-                  <a:srgbClr val="13293D"/>
-                </a:solidFill>
-                <a:latin typeface="Inter" pitchFamily="34" charset="0"/>
-                <a:ea typeface="Inter" pitchFamily="34" charset="-122"/>
-                <a:cs typeface="Inter" pitchFamily="34" charset="-120"/>
-              </a:rPr>
-              <a:t>Voice</a:t>
-            </a:r>
-            <a:endParaRPr lang="en-US" sz="2000" dirty="0"/>
-          </a:p>
-        </p:txBody>
-      </p:sp>
-      <p:sp>
-        <p:nvSpPr>
-          <p:cNvPr id="23" name="Text 20"/>
-          <p:cNvSpPr/>
-          <p:nvPr/>
-        </p:nvSpPr>
-        <p:spPr>
-          <a:xfrm>
-            <a:off x="4636008" y="3429000"/>
-            <a:ext cx="3063240" cy="914400"/>
-          </a:xfrm>
-          <a:prstGeom prst="rect">
-            <a:avLst/>
-          </a:prstGeom>
-          <a:noFill/>
-          <a:ln/>
-        </p:spPr>
-        <p:txBody>
-          <a:bodyPr wrap="square" lIns="0" tIns="0" rIns="0" bIns="0" rtlCol="0" anchor="ctr"/>
-          <a:lstStyle/>
-          <a:p>
-            <a:pPr algn="ctr" indent="0" marL="0">
-              <a:buNone/>
-            </a:pPr>
-            <a:r>
-              <a:rPr lang="en-US" sz="1500" dirty="0">
-                <a:solidFill>
-                  <a:srgbClr val="1B1F24"/>
-                </a:solidFill>
-                <a:latin typeface="Inter" pitchFamily="34" charset="0"/>
-                <a:ea typeface="Inter" pitchFamily="34" charset="-122"/>
-                <a:cs typeface="Inter" pitchFamily="34" charset="-120"/>
-              </a:rPr>
-              <a:t>Does it sound like you? Read it aloud.</a:t>
-            </a:r>
-            <a:endParaRPr lang="en-US" sz="1500" dirty="0"/>
-          </a:p>
-        </p:txBody>
-      </p:sp>
-      <p:sp>
-        <p:nvSpPr>
-          <p:cNvPr id="24" name="Shape 21"/>
-          <p:cNvSpPr/>
-          <p:nvPr/>
-        </p:nvSpPr>
-        <p:spPr>
-          <a:xfrm>
-            <a:off x="8174736" y="1554480"/>
-            <a:ext cx="3520440" cy="2926080"/>
+            <a:off x="640080" y="3886200"/>
+            <a:ext cx="4160520" cy="1051560"/>
           </a:xfrm>
           <a:prstGeom prst="roundRect">
             <a:avLst>
-              <a:gd name="adj" fmla="val 2813"/>
+              <a:gd name="adj" fmla="val 7826"/>
             </a:avLst>
           </a:prstGeom>
           <a:solidFill>
@@ -12536,24 +12606,104 @@
       </p:sp>
       <p:sp>
         <p:nvSpPr>
-          <p:cNvPr id="25" name="Shape 22"/>
-          <p:cNvSpPr/>
-          <p:nvPr/>
-        </p:nvSpPr>
-        <p:spPr>
-          <a:xfrm>
-            <a:off x="9473184" y="1828800"/>
-            <a:ext cx="914400" cy="914400"/>
-          </a:xfrm>
-          <a:prstGeom prst="ellipse">
-            <a:avLst/>
+          <p:cNvPr id="21" name="Text 18"/>
+          <p:cNvSpPr/>
+          <p:nvPr/>
+        </p:nvSpPr>
+        <p:spPr>
+          <a:xfrm>
+            <a:off x="914400" y="3995928"/>
+            <a:ext cx="3657600" cy="365760"/>
+          </a:xfrm>
+          <a:prstGeom prst="rect">
+            <a:avLst/>
+          </a:prstGeom>
+          <a:noFill/>
+          <a:ln/>
+        </p:spPr>
+        <p:txBody>
+          <a:bodyPr wrap="square" lIns="0" tIns="0" rIns="0" bIns="0" rtlCol="0" anchor="ctr"/>
+          <a:lstStyle/>
+          <a:p>
+            <a:pPr indent="0" marL="0">
+              <a:buNone/>
+            </a:pPr>
+            <a:r>
+              <a:rPr lang="en-US" sz="1700" b="1" dirty="0">
+                <a:solidFill>
+                  <a:srgbClr val="13293D"/>
+                </a:solidFill>
+                <a:latin typeface="Inter" pitchFamily="34" charset="0"/>
+                <a:ea typeface="Inter" pitchFamily="34" charset="-122"/>
+                <a:cs typeface="Inter" pitchFamily="34" charset="-120"/>
+              </a:rPr>
+              <a:t>3 · Details</a:t>
+            </a:r>
+            <a:endParaRPr lang="en-US" sz="1700" dirty="0"/>
+          </a:p>
+        </p:txBody>
+      </p:sp>
+      <p:sp>
+        <p:nvSpPr>
+          <p:cNvPr id="22" name="Text 19"/>
+          <p:cNvSpPr/>
+          <p:nvPr/>
+        </p:nvSpPr>
+        <p:spPr>
+          <a:xfrm>
+            <a:off x="914400" y="4361688"/>
+            <a:ext cx="3657600" cy="502920"/>
+          </a:xfrm>
+          <a:prstGeom prst="rect">
+            <a:avLst/>
+          </a:prstGeom>
+          <a:noFill/>
+          <a:ln/>
+        </p:spPr>
+        <p:txBody>
+          <a:bodyPr wrap="square" lIns="0" tIns="0" rIns="0" bIns="0" rtlCol="0" anchor="ctr"/>
+          <a:lstStyle/>
+          <a:p>
+            <a:pPr indent="0" marL="0">
+              <a:buNone/>
+            </a:pPr>
+            <a:r>
+              <a:rPr lang="en-US" sz="1350" dirty="0">
+                <a:solidFill>
+                  <a:srgbClr val="1B1F24"/>
+                </a:solidFill>
+                <a:latin typeface="Inter" pitchFamily="34" charset="0"/>
+                <a:ea typeface="Inter" pitchFamily="34" charset="-122"/>
+                <a:cs typeface="Inter" pitchFamily="34" charset="-120"/>
+              </a:rPr>
+              <a:t>Length, level, layout: make them exact.</a:t>
+            </a:r>
+            <a:endParaRPr lang="en-US" sz="1350" dirty="0"/>
+          </a:p>
+        </p:txBody>
+      </p:sp>
+      <p:sp>
+        <p:nvSpPr>
+          <p:cNvPr id="23" name="Shape 20"/>
+          <p:cNvSpPr/>
+          <p:nvPr/>
+        </p:nvSpPr>
+        <p:spPr>
+          <a:xfrm>
+            <a:off x="5029200" y="1508760"/>
+            <a:ext cx="6629400" cy="3566160"/>
+          </a:xfrm>
+          <a:prstGeom prst="roundRect">
+            <a:avLst>
+              <a:gd name="adj" fmla="val 2308"/>
+            </a:avLst>
           </a:prstGeom>
           <a:solidFill>
-            <a:srgbClr val="2A9D8F"/>
+            <a:srgbClr val="EAF5F3"/>
           </a:solidFill>
           <a:ln w="12700">
             <a:solidFill>
-              <a:srgbClr val="2A9D8F"/>
+              <a:srgbClr val="EAF5F3"/>
             </a:solidFill>
             <a:prstDash val="solid"/>
           </a:ln>
@@ -12561,130 +12711,181 @@
       </p:sp>
       <p:sp>
         <p:nvSpPr>
+          <p:cNvPr id="24" name="Text 21"/>
+          <p:cNvSpPr/>
+          <p:nvPr/>
+        </p:nvSpPr>
+        <p:spPr>
+          <a:xfrm>
+            <a:off x="5303520" y="1691640"/>
+            <a:ext cx="6126480" cy="292608"/>
+          </a:xfrm>
+          <a:prstGeom prst="rect">
+            <a:avLst/>
+          </a:prstGeom>
+          <a:noFill/>
+          <a:ln/>
+        </p:spPr>
+        <p:txBody>
+          <a:bodyPr wrap="square" lIns="0" tIns="0" rIns="0" bIns="0" rtlCol="0" anchor="ctr"/>
+          <a:lstStyle/>
+          <a:p>
+            <a:pPr indent="0" marL="0">
+              <a:buNone/>
+            </a:pPr>
+            <a:r>
+              <a:rPr lang="en-US" sz="1250" b="1" spc="150" kern="0" dirty="0">
+                <a:solidFill>
+                  <a:srgbClr val="2A9D8F"/>
+                </a:solidFill>
+                <a:latin typeface="Inter" pitchFamily="34" charset="0"/>
+                <a:ea typeface="Inter" pitchFamily="34" charset="-122"/>
+                <a:cs typeface="Inter" pitchFamily="34" charset="-120"/>
+              </a:rPr>
+              <a:t>MS. RIVERA'S REVIEW PROMPT · STEP 2 · HER THREE ROUNDS</a:t>
+            </a:r>
+            <a:endParaRPr lang="en-US" sz="1250" dirty="0"/>
+          </a:p>
+        </p:txBody>
+      </p:sp>
+      <p:sp>
+        <p:nvSpPr>
+          <p:cNvPr id="25" name="Text 22"/>
+          <p:cNvSpPr/>
+          <p:nvPr/>
+        </p:nvSpPr>
+        <p:spPr>
+          <a:xfrm>
+            <a:off x="5303520" y="2103120"/>
+            <a:ext cx="6080760" cy="2834640"/>
+          </a:xfrm>
+          <a:prstGeom prst="rect">
+            <a:avLst/>
+          </a:prstGeom>
+          <a:noFill/>
+          <a:ln/>
+        </p:spPr>
+        <p:txBody>
+          <a:bodyPr wrap="square" lIns="0" tIns="0" rIns="0" bIns="0" rtlCol="0" anchor="t"/>
+          <a:lstStyle/>
+          <a:p>
+            <a:pPr indent="0" marL="0">
+              <a:lnSpc>
+                <a:spcPct val="125000"/>
+              </a:lnSpc>
+              <a:buNone/>
+            </a:pPr>
+            <a:r>
+              <a:rPr lang="en-US" sz="1650" b="1" dirty="0">
+                <a:solidFill>
+                  <a:srgbClr val="13293D"/>
+                </a:solidFill>
+                <a:latin typeface="Inter" pitchFamily="34" charset="0"/>
+                <a:ea typeface="Inter" pitchFamily="34" charset="-122"/>
+                <a:cs typeface="Inter" pitchFamily="34" charset="-120"/>
+              </a:rPr>
+              <a:t>Content  </a:t>
+            </a:r>
+            <a:pPr indent="0" marL="0">
+              <a:lnSpc>
+                <a:spcPct val="125000"/>
+              </a:lnSpc>
+              <a:buNone/>
+            </a:pPr>
+            <a:r>
+              <a:rPr lang="en-US" sz="1650" i="1" dirty="0">
+                <a:solidFill>
+                  <a:srgbClr val="1B1F24"/>
+                </a:solidFill>
+                <a:latin typeface="Inter" pitchFamily="34" charset="0"/>
+                <a:ea typeface="Inter" pitchFamily="34" charset="-122"/>
+                <a:cs typeface="Inter" pitchFamily="34" charset="-120"/>
+              </a:rPr>
+              <a:t>“Question 3 is mixed numbers; we haven’t gotten there. Swap in a comparing-fractions item.”
+</a:t>
+            </a:r>
+            <a:pPr indent="0" marL="0">
+              <a:lnSpc>
+                <a:spcPct val="125000"/>
+              </a:lnSpc>
+              <a:buNone/>
+            </a:pPr>
+            <a:r>
+              <a:rPr lang="en-US" sz="1650" b="1" dirty="0">
+                <a:solidFill>
+                  <a:srgbClr val="13293D"/>
+                </a:solidFill>
+                <a:latin typeface="Inter" pitchFamily="34" charset="0"/>
+                <a:ea typeface="Inter" pitchFamily="34" charset="-122"/>
+                <a:cs typeface="Inter" pitchFamily="34" charset="-120"/>
+              </a:rPr>
+              <a:t>Voice  </a:t>
+            </a:r>
+            <a:pPr indent="0" marL="0">
+              <a:lnSpc>
+                <a:spcPct val="125000"/>
+              </a:lnSpc>
+              <a:buNone/>
+            </a:pPr>
+            <a:r>
+              <a:rPr lang="en-US" sz="1650" i="1" dirty="0">
+                <a:solidFill>
+                  <a:srgbClr val="1B1F24"/>
+                </a:solidFill>
+                <a:latin typeface="Inter" pitchFamily="34" charset="0"/>
+                <a:ea typeface="Inter" pitchFamily="34" charset="-122"/>
+                <a:cs typeface="Inter" pitchFamily="34" charset="-120"/>
+              </a:rPr>
+              <a:t>“The directions don’t sound like me. Warmer, and lose ‘utilize.’”
+</a:t>
+            </a:r>
+            <a:pPr indent="0" marL="0">
+              <a:lnSpc>
+                <a:spcPct val="125000"/>
+              </a:lnSpc>
+              <a:buNone/>
+            </a:pPr>
+            <a:r>
+              <a:rPr lang="en-US" sz="1650" b="1" dirty="0">
+                <a:solidFill>
+                  <a:srgbClr val="13293D"/>
+                </a:solidFill>
+                <a:latin typeface="Inter" pitchFamily="34" charset="0"/>
+                <a:ea typeface="Inter" pitchFamily="34" charset="-122"/>
+                <a:cs typeface="Inter" pitchFamily="34" charset="-120"/>
+              </a:rPr>
+              <a:t>Details  </a:t>
+            </a:r>
+            <a:pPr indent="0" marL="0">
+              <a:lnSpc>
+                <a:spcPct val="125000"/>
+              </a:lnSpc>
+              <a:buNone/>
+            </a:pPr>
+            <a:r>
+              <a:rPr lang="en-US" sz="1650" i="1" dirty="0">
+                <a:solidFill>
+                  <a:srgbClr val="1B1F24"/>
+                </a:solidFill>
+                <a:latin typeface="Inter" pitchFamily="34" charset="0"/>
+                <a:ea typeface="Inter" pitchFamily="34" charset="-122"/>
+                <a:cs typeface="Inter" pitchFamily="34" charset="-120"/>
+              </a:rPr>
+              <a:t>“Exactly ten questions, numbered, answer key on its own page.”</a:t>
+            </a:r>
+            <a:endParaRPr lang="en-US" sz="1650" dirty="0"/>
+          </a:p>
+        </p:txBody>
+      </p:sp>
+      <p:sp>
+        <p:nvSpPr>
           <p:cNvPr id="26" name="Text 23"/>
           <p:cNvSpPr/>
           <p:nvPr/>
         </p:nvSpPr>
         <p:spPr>
           <a:xfrm>
-            <a:off x="9473184" y="1828800"/>
-            <a:ext cx="914400" cy="914400"/>
-          </a:xfrm>
-          <a:prstGeom prst="rect">
-            <a:avLst/>
-          </a:prstGeom>
-          <a:noFill/>
-          <a:ln/>
-        </p:spPr>
-        <p:txBody>
-          <a:bodyPr wrap="square" lIns="0" tIns="0" rIns="0" bIns="0" rtlCol="0" anchor="ctr"/>
-          <a:lstStyle/>
-          <a:p>
-            <a:pPr algn="ctr" indent="0" marL="0">
-              <a:buNone/>
-            </a:pPr>
-            <a:r>
-              <a:rPr lang="en-US" sz="3000" b="1" dirty="0">
-                <a:solidFill>
-                  <a:srgbClr val="FFFFFF"/>
-                </a:solidFill>
-                <a:latin typeface="Inter" pitchFamily="34" charset="0"/>
-                <a:ea typeface="Inter" pitchFamily="34" charset="-122"/>
-                <a:cs typeface="Inter" pitchFamily="34" charset="-120"/>
-              </a:rPr>
-              <a:t>3</a:t>
-            </a:r>
-            <a:endParaRPr lang="en-US" sz="3000" dirty="0"/>
-          </a:p>
-        </p:txBody>
-      </p:sp>
-      <p:sp>
-        <p:nvSpPr>
-          <p:cNvPr id="27" name="Text 24"/>
-          <p:cNvSpPr/>
-          <p:nvPr/>
-        </p:nvSpPr>
-        <p:spPr>
-          <a:xfrm>
-            <a:off x="8403336" y="2926080"/>
-            <a:ext cx="3063240" cy="457200"/>
-          </a:xfrm>
-          <a:prstGeom prst="rect">
-            <a:avLst/>
-          </a:prstGeom>
-          <a:noFill/>
-          <a:ln/>
-        </p:spPr>
-        <p:txBody>
-          <a:bodyPr wrap="square" lIns="0" tIns="0" rIns="0" bIns="0" rtlCol="0" anchor="ctr"/>
-          <a:lstStyle/>
-          <a:p>
-            <a:pPr algn="ctr" indent="0" marL="0">
-              <a:buNone/>
-            </a:pPr>
-            <a:r>
-              <a:rPr lang="en-US" sz="2000" b="1" dirty="0">
-                <a:solidFill>
-                  <a:srgbClr val="13293D"/>
-                </a:solidFill>
-                <a:latin typeface="Inter" pitchFamily="34" charset="0"/>
-                <a:ea typeface="Inter" pitchFamily="34" charset="-122"/>
-                <a:cs typeface="Inter" pitchFamily="34" charset="-120"/>
-              </a:rPr>
-              <a:t>Details</a:t>
-            </a:r>
-            <a:endParaRPr lang="en-US" sz="2000" dirty="0"/>
-          </a:p>
-        </p:txBody>
-      </p:sp>
-      <p:sp>
-        <p:nvSpPr>
-          <p:cNvPr id="28" name="Text 25"/>
-          <p:cNvSpPr/>
-          <p:nvPr/>
-        </p:nvSpPr>
-        <p:spPr>
-          <a:xfrm>
-            <a:off x="8403336" y="3429000"/>
-            <a:ext cx="3063240" cy="914400"/>
-          </a:xfrm>
-          <a:prstGeom prst="rect">
-            <a:avLst/>
-          </a:prstGeom>
-          <a:noFill/>
-          <a:ln/>
-        </p:spPr>
-        <p:txBody>
-          <a:bodyPr wrap="square" lIns="0" tIns="0" rIns="0" bIns="0" rtlCol="0" anchor="ctr"/>
-          <a:lstStyle/>
-          <a:p>
-            <a:pPr algn="ctr" indent="0" marL="0">
-              <a:buNone/>
-            </a:pPr>
-            <a:r>
-              <a:rPr lang="en-US" sz="1500" dirty="0">
-                <a:solidFill>
-                  <a:srgbClr val="1B1F24"/>
-                </a:solidFill>
-                <a:latin typeface="Inter" pitchFamily="34" charset="0"/>
-                <a:ea typeface="Inter" pitchFamily="34" charset="-122"/>
-                <a:cs typeface="Inter" pitchFamily="34" charset="-120"/>
-              </a:rPr>
-              <a:t>Length, level, layout: make them exact.</a:t>
-            </a:r>
-            <a:endParaRPr lang="en-US" sz="1500" dirty="0"/>
-          </a:p>
-        </p:txBody>
-      </p:sp>
-      <p:sp>
-        <p:nvSpPr>
-          <p:cNvPr id="29" name="Text 26"/>
-          <p:cNvSpPr/>
-          <p:nvPr/>
-        </p:nvSpPr>
-        <p:spPr>
-          <a:xfrm>
-            <a:off x="640080" y="4937760"/>
+            <a:off x="640080" y="5303520"/>
             <a:ext cx="10972800" cy="457200"/>
           </a:xfrm>
           <a:prstGeom prst="rect">
@@ -13064,7 +13265,7 @@
                 <a:ea typeface="Inter" pitchFamily="34" charset="-122"/>
                 <a:cs typeface="Inter" pitchFamily="34" charset="-120"/>
               </a:rPr>
-              <a:t>Her template, saved: her name, one line on what it's for, in the staff doc.</a:t>
+              <a:t>Her review prompt, bracketed into a template and pasted into the staff doc.</a:t>
             </a:r>
             <a:endParaRPr lang="en-US" sz="1000" dirty="0"/>
           </a:p>
@@ -13156,8 +13357,8 @@
         </p:nvSpPr>
         <p:spPr>
           <a:xfrm>
-            <a:off x="640080" y="1463040"/>
-            <a:ext cx="10908792" cy="2286000"/>
+            <a:off x="640080" y="1508760"/>
+            <a:ext cx="4846320" cy="3108960"/>
           </a:xfrm>
           <a:prstGeom prst="rect">
             <a:avLst/>
@@ -13177,7 +13378,7 @@
               <a:buChar char="•"/>
             </a:pPr>
             <a:r>
-              <a:rPr lang="en-US" sz="2100" dirty="0">
+              <a:rPr lang="en-US" sz="1700" dirty="0">
                 <a:solidFill>
                   <a:srgbClr val="1B1F24"/>
                 </a:solidFill>
@@ -13187,7 +13388,7 @@
               </a:rPr>
               <a:t>Replace the specifics with blanks: [topic], [grade], [number of questions]</a:t>
             </a:r>
-            <a:endParaRPr lang="en-US" sz="2100" dirty="0"/>
+            <a:endParaRPr lang="en-US" sz="1700" dirty="0"/>
           </a:p>
           <a:p>
             <a:pPr marL="342900" indent="-342900">
@@ -13198,7 +13399,7 @@
               <a:buChar char="•"/>
             </a:pPr>
             <a:r>
-              <a:rPr lang="en-US" sz="2100" dirty="0">
+              <a:rPr lang="en-US" sz="1700" dirty="0">
                 <a:solidFill>
                   <a:srgbClr val="1B1F24"/>
                 </a:solidFill>
@@ -13208,7 +13409,7 @@
               </a:rPr>
               <a:t>Paste the final template into the staff prompt doc</a:t>
             </a:r>
-            <a:endParaRPr lang="en-US" sz="2100" dirty="0"/>
+            <a:endParaRPr lang="en-US" sz="1700" dirty="0"/>
           </a:p>
           <a:p>
             <a:pPr marL="342900" indent="-342900">
@@ -13219,7 +13420,7 @@
               <a:buChar char="•"/>
             </a:pPr>
             <a:r>
-              <a:rPr lang="en-US" sz="2100" dirty="0">
+              <a:rPr lang="en-US" sz="1700" dirty="0">
                 <a:solidFill>
                   <a:srgbClr val="1B1F24"/>
                 </a:solidFill>
@@ -13229,7 +13430,7 @@
               </a:rPr>
               <a:t>Add your name and one line: what it’s for</a:t>
             </a:r>
-            <a:endParaRPr lang="en-US" sz="2100" dirty="0"/>
+            <a:endParaRPr lang="en-US" sz="1700" dirty="0"/>
           </a:p>
         </p:txBody>
       </p:sp>
@@ -13241,12 +13442,12 @@
         </p:nvSpPr>
         <p:spPr>
           <a:xfrm>
-            <a:off x="640080" y="3931920"/>
-            <a:ext cx="10972800" cy="1737360"/>
+            <a:off x="5806440" y="1508760"/>
+            <a:ext cx="5806440" cy="3429000"/>
           </a:xfrm>
           <a:prstGeom prst="roundRect">
             <a:avLst>
-              <a:gd name="adj" fmla="val 4737"/>
+              <a:gd name="adj" fmla="val 2400"/>
             </a:avLst>
           </a:prstGeom>
           <a:solidFill>
@@ -13268,24 +13469,66 @@
         </p:nvSpPr>
         <p:spPr>
           <a:xfrm>
-            <a:off x="960120" y="4160520"/>
-            <a:ext cx="10332720" cy="1280160"/>
-          </a:xfrm>
-          <a:prstGeom prst="rect">
-            <a:avLst/>
-          </a:prstGeom>
-          <a:noFill/>
-          <a:ln/>
-        </p:spPr>
-        <p:txBody>
-          <a:bodyPr wrap="square" lIns="0" tIns="0" rIns="0" bIns="0" rtlCol="0" anchor="ctr"/>
-          <a:lstStyle/>
-          <a:p>
-            <a:pPr indent="0" marL="0">
-              <a:buNone/>
-            </a:pPr>
-            <a:r>
-              <a:rPr lang="en-US" sz="2100" b="1" dirty="0">
+            <a:off x="6080760" y="1691640"/>
+            <a:ext cx="5349240" cy="292608"/>
+          </a:xfrm>
+          <a:prstGeom prst="rect">
+            <a:avLst/>
+          </a:prstGeom>
+          <a:noFill/>
+          <a:ln/>
+        </p:spPr>
+        <p:txBody>
+          <a:bodyPr wrap="square" lIns="0" tIns="0" rIns="0" bIns="0" rtlCol="0" anchor="ctr"/>
+          <a:lstStyle/>
+          <a:p>
+            <a:pPr indent="0" marL="0">
+              <a:buNone/>
+            </a:pPr>
+            <a:r>
+              <a:rPr lang="en-US" sz="1200" b="1" spc="120" kern="0" dirty="0">
+                <a:solidFill>
+                  <a:srgbClr val="2A9D8F"/>
+                </a:solidFill>
+                <a:latin typeface="Inter" pitchFamily="34" charset="0"/>
+                <a:ea typeface="Inter" pitchFamily="34" charset="-122"/>
+                <a:cs typeface="Inter" pitchFamily="34" charset="-120"/>
+              </a:rPr>
+              <a:t>MS. RIVERA'S REVIEW PROMPT · STEP 3 · HER TEMPLATE, SAVED</a:t>
+            </a:r>
+            <a:endParaRPr lang="en-US" sz="1200" dirty="0"/>
+          </a:p>
+        </p:txBody>
+      </p:sp>
+      <p:sp>
+        <p:nvSpPr>
+          <p:cNvPr id="17" name="Text 14"/>
+          <p:cNvSpPr/>
+          <p:nvPr/>
+        </p:nvSpPr>
+        <p:spPr>
+          <a:xfrm>
+            <a:off x="6080760" y="2103120"/>
+            <a:ext cx="5257800" cy="2103120"/>
+          </a:xfrm>
+          <a:prstGeom prst="rect">
+            <a:avLst/>
+          </a:prstGeom>
+          <a:noFill/>
+          <a:ln/>
+        </p:spPr>
+        <p:txBody>
+          <a:bodyPr wrap="square" lIns="0" tIns="0" rIns="0" bIns="0" rtlCol="0" anchor="t"/>
+          <a:lstStyle/>
+          <a:p>
+            <a:pPr indent="0" marL="0">
+              <a:lnSpc>
+                <a:spcPct val="120000"/>
+              </a:lnSpc>
+              <a:buNone/>
+            </a:pPr>
+            <a:r>
+              <a:rPr lang="en-US" sz="1650" b="1" i="1" dirty="0">
                 <a:solidFill>
                   <a:srgbClr val="13293D"/>
                 </a:solidFill>
@@ -13293,9 +13536,114 @@
                 <a:ea typeface="Inter" pitchFamily="34" charset="-122"/>
                 <a:cs typeface="Inter" pitchFamily="34" charset="-120"/>
               </a:rPr>
+              <a:t>“You are an experienced [grade] teacher. Write a [number]-question review on [topic] for a class that still confuses [what they mix up]. Mix multiple choice and short answer. Include an answer key.”</a:t>
+            </a:r>
+            <a:endParaRPr lang="en-US" sz="1650" dirty="0"/>
+          </a:p>
+        </p:txBody>
+      </p:sp>
+      <p:sp>
+        <p:nvSpPr>
+          <p:cNvPr id="18" name="Text 15"/>
+          <p:cNvSpPr/>
+          <p:nvPr/>
+        </p:nvSpPr>
+        <p:spPr>
+          <a:xfrm>
+            <a:off x="6080760" y="4343400"/>
+            <a:ext cx="5257800" cy="457200"/>
+          </a:xfrm>
+          <a:prstGeom prst="rect">
+            <a:avLst/>
+          </a:prstGeom>
+          <a:noFill/>
+          <a:ln/>
+        </p:spPr>
+        <p:txBody>
+          <a:bodyPr wrap="square" lIns="0" tIns="0" rIns="0" bIns="0" rtlCol="0" anchor="ctr"/>
+          <a:lstStyle/>
+          <a:p>
+            <a:pPr indent="0" marL="0">
+              <a:buNone/>
+            </a:pPr>
+            <a:r>
+              <a:rPr lang="en-US" sz="1200" dirty="0">
+                <a:solidFill>
+                  <a:srgbClr val="5B6B7A"/>
+                </a:solidFill>
+                <a:latin typeface="Inter" pitchFamily="34" charset="0"/>
+                <a:ea typeface="Inter" pitchFamily="34" charset="-122"/>
+                <a:cs typeface="Inter" pitchFamily="34" charset="-120"/>
+              </a:rPr>
+              <a:t>In the staff doc: Ms. Rivera · “weekly review questions, any topic”</a:t>
+            </a:r>
+            <a:endParaRPr lang="en-US" sz="1200" dirty="0"/>
+          </a:p>
+        </p:txBody>
+      </p:sp>
+      <p:sp>
+        <p:nvSpPr>
+          <p:cNvPr id="19" name="Shape 16"/>
+          <p:cNvSpPr/>
+          <p:nvPr/>
+        </p:nvSpPr>
+        <p:spPr>
+          <a:xfrm>
+            <a:off x="640080" y="5120640"/>
+            <a:ext cx="10972800" cy="914400"/>
+          </a:xfrm>
+          <a:prstGeom prst="roundRect">
+            <a:avLst>
+              <a:gd name="adj" fmla="val 9000"/>
+            </a:avLst>
+          </a:prstGeom>
+          <a:solidFill>
+            <a:srgbClr val="EAF5F3"/>
+          </a:solidFill>
+          <a:ln w="12700">
+            <a:solidFill>
+              <a:srgbClr val="EAF5F3"/>
+            </a:solidFill>
+            <a:prstDash val="solid"/>
+          </a:ln>
+        </p:spPr>
+      </p:sp>
+      <p:sp>
+        <p:nvSpPr>
+          <p:cNvPr id="20" name="Text 17"/>
+          <p:cNvSpPr/>
+          <p:nvPr/>
+        </p:nvSpPr>
+        <p:spPr>
+          <a:xfrm>
+            <a:off x="960120" y="5212080"/>
+            <a:ext cx="10332720" cy="731520"/>
+          </a:xfrm>
+          <a:prstGeom prst="rect">
+            <a:avLst/>
+          </a:prstGeom>
+          <a:noFill/>
+          <a:ln/>
+        </p:spPr>
+        <p:txBody>
+          <a:bodyPr wrap="square" lIns="0" tIns="0" rIns="0" bIns="0" rtlCol="0" anchor="ctr"/>
+          <a:lstStyle/>
+          <a:p>
+            <a:pPr indent="0" marL="0">
+              <a:buNone/>
+            </a:pPr>
+            <a:r>
+              <a:rPr lang="en-US" sz="1800" b="1" dirty="0">
+                <a:solidFill>
+                  <a:srgbClr val="13293D"/>
+                </a:solidFill>
+                <a:latin typeface="Inter" pitchFamily="34" charset="0"/>
+                <a:ea typeface="Inter" pitchFamily="34" charset="-122"/>
+                <a:cs typeface="Inter" pitchFamily="34" charset="-120"/>
+              </a:rPr>
               <a:t>You just wrote the first entry in your professional prompt library. Kit 18 grows it into a whole collection.</a:t>
             </a:r>
-            <a:endParaRPr lang="en-US" sz="2100" dirty="0"/>
+            <a:endParaRPr lang="en-US" sz="1800" dirty="0"/>
           </a:p>
         </p:txBody>
       </p:sp>
@@ -13648,7 +13996,7 @@
                 <a:ea typeface="Inter" pitchFamily="34" charset="-122"/>
                 <a:cs typeface="Inter" pitchFamily="34" charset="-120"/>
               </a:rPr>
-              <a:t>Her before and after, read aloud: the delta is the lesson.</a:t>
+              <a:t>Her review prompt, before and after: the delta is the lesson.</a:t>
             </a:r>
             <a:endParaRPr lang="en-US" sz="1000" dirty="0"/>
           </a:p>
@@ -14166,7 +14514,7 @@
                 <a:ea typeface="Inter" pitchFamily="34" charset="-122"/>
                 <a:cs typeface="Inter" pitchFamily="34" charset="-120"/>
               </a:rPr>
-              <a:t>Her library: one entry today. It compounds from here.</a:t>
+              <a:t>Her library: one entry today, the review-questions template. It compounds.</a:t>
             </a:r>
             <a:endParaRPr lang="en-US" sz="1000" dirty="0"/>
           </a:p>
@@ -17841,7 +18189,7 @@
         <p:spPr>
           <a:xfrm>
             <a:off x="548640" y="384048"/>
-            <a:ext cx="11091672" cy="777240"/>
+            <a:ext cx="7955280" cy="777240"/>
           </a:xfrm>
           <a:prstGeom prst="rect">
             <a:avLst/>

</xml_diff>